<commit_message>
Example Websocket App that doesnt work yet
</commit_message>
<xml_diff>
--- a/docs/ProjectDesignDiagrams/ProjectDesignDiagrams.pptx
+++ b/docs/ProjectDesignDiagrams/ProjectDesignDiagrams.pptx
@@ -6,6 +6,7 @@
   </p:sldMasterIdLst>
   <p:sldIdLst>
     <p:sldId id="257" r:id="rId2"/>
+    <p:sldId id="258" r:id="rId3"/>
   </p:sldIdLst>
   <p:sldSz cx="6858000" cy="12192000"/>
   <p:notesSz cx="6858000" cy="9144000"/>
@@ -243,7 +244,7 @@
           <a:p>
             <a:fld id="{D362ADB5-A607-4434-A170-49B20D0F2AF8}" type="datetimeFigureOut">
               <a:rPr lang="en-US" smtClean="0"/>
-              <a:t>2/1/2026</a:t>
+              <a:t>2/11/2026</a:t>
             </a:fld>
             <a:endParaRPr lang="en-US"/>
           </a:p>
@@ -413,7 +414,7 @@
           <a:p>
             <a:fld id="{D362ADB5-A607-4434-A170-49B20D0F2AF8}" type="datetimeFigureOut">
               <a:rPr lang="en-US" smtClean="0"/>
-              <a:t>2/1/2026</a:t>
+              <a:t>2/11/2026</a:t>
             </a:fld>
             <a:endParaRPr lang="en-US"/>
           </a:p>
@@ -593,7 +594,7 @@
           <a:p>
             <a:fld id="{D362ADB5-A607-4434-A170-49B20D0F2AF8}" type="datetimeFigureOut">
               <a:rPr lang="en-US" smtClean="0"/>
-              <a:t>2/1/2026</a:t>
+              <a:t>2/11/2026</a:t>
             </a:fld>
             <a:endParaRPr lang="en-US"/>
           </a:p>
@@ -763,7 +764,7 @@
           <a:p>
             <a:fld id="{D362ADB5-A607-4434-A170-49B20D0F2AF8}" type="datetimeFigureOut">
               <a:rPr lang="en-US" smtClean="0"/>
-              <a:t>2/1/2026</a:t>
+              <a:t>2/11/2026</a:t>
             </a:fld>
             <a:endParaRPr lang="en-US"/>
           </a:p>
@@ -1009,7 +1010,7 @@
           <a:p>
             <a:fld id="{D362ADB5-A607-4434-A170-49B20D0F2AF8}" type="datetimeFigureOut">
               <a:rPr lang="en-US" smtClean="0"/>
-              <a:t>2/1/2026</a:t>
+              <a:t>2/11/2026</a:t>
             </a:fld>
             <a:endParaRPr lang="en-US"/>
           </a:p>
@@ -1241,7 +1242,7 @@
           <a:p>
             <a:fld id="{D362ADB5-A607-4434-A170-49B20D0F2AF8}" type="datetimeFigureOut">
               <a:rPr lang="en-US" smtClean="0"/>
-              <a:t>2/1/2026</a:t>
+              <a:t>2/11/2026</a:t>
             </a:fld>
             <a:endParaRPr lang="en-US"/>
           </a:p>
@@ -1608,7 +1609,7 @@
           <a:p>
             <a:fld id="{D362ADB5-A607-4434-A170-49B20D0F2AF8}" type="datetimeFigureOut">
               <a:rPr lang="en-US" smtClean="0"/>
-              <a:t>2/1/2026</a:t>
+              <a:t>2/11/2026</a:t>
             </a:fld>
             <a:endParaRPr lang="en-US"/>
           </a:p>
@@ -1726,7 +1727,7 @@
           <a:p>
             <a:fld id="{D362ADB5-A607-4434-A170-49B20D0F2AF8}" type="datetimeFigureOut">
               <a:rPr lang="en-US" smtClean="0"/>
-              <a:t>2/1/2026</a:t>
+              <a:t>2/11/2026</a:t>
             </a:fld>
             <a:endParaRPr lang="en-US"/>
           </a:p>
@@ -1821,7 +1822,7 @@
           <a:p>
             <a:fld id="{D362ADB5-A607-4434-A170-49B20D0F2AF8}" type="datetimeFigureOut">
               <a:rPr lang="en-US" smtClean="0"/>
-              <a:t>2/1/2026</a:t>
+              <a:t>2/11/2026</a:t>
             </a:fld>
             <a:endParaRPr lang="en-US"/>
           </a:p>
@@ -2098,7 +2099,7 @@
           <a:p>
             <a:fld id="{D362ADB5-A607-4434-A170-49B20D0F2AF8}" type="datetimeFigureOut">
               <a:rPr lang="en-US" smtClean="0"/>
-              <a:t>2/1/2026</a:t>
+              <a:t>2/11/2026</a:t>
             </a:fld>
             <a:endParaRPr lang="en-US"/>
           </a:p>
@@ -2355,7 +2356,7 @@
           <a:p>
             <a:fld id="{D362ADB5-A607-4434-A170-49B20D0F2AF8}" type="datetimeFigureOut">
               <a:rPr lang="en-US" smtClean="0"/>
-              <a:t>2/1/2026</a:t>
+              <a:t>2/11/2026</a:t>
             </a:fld>
             <a:endParaRPr lang="en-US"/>
           </a:p>
@@ -2568,7 +2569,7 @@
           <a:p>
             <a:fld id="{D362ADB5-A607-4434-A170-49B20D0F2AF8}" type="datetimeFigureOut">
               <a:rPr lang="en-US" smtClean="0"/>
-              <a:t>2/1/2026</a:t>
+              <a:t>2/11/2026</a:t>
             </a:fld>
             <a:endParaRPr lang="en-US"/>
           </a:p>
@@ -4421,6 +4422,538 @@
 </p:sld>
 </file>
 
+<file path=ppt/slides/slide2.xml><?xml version="1.0" encoding="utf-8"?>
+<p:sld xmlns:a="http://schemas.openxmlformats.org/drawingml/2006/main" xmlns:r="http://schemas.openxmlformats.org/officeDocument/2006/relationships" xmlns:p="http://schemas.openxmlformats.org/presentationml/2006/main">
+  <p:cSld>
+    <p:spTree>
+      <p:nvGrpSpPr>
+        <p:cNvPr id="1" name=""/>
+        <p:cNvGrpSpPr/>
+        <p:nvPr/>
+      </p:nvGrpSpPr>
+      <p:grpSpPr>
+        <a:xfrm>
+          <a:off x="0" y="0"/>
+          <a:ext cx="0" cy="0"/>
+          <a:chOff x="0" y="0"/>
+          <a:chExt cx="0" cy="0"/>
+        </a:xfrm>
+      </p:grpSpPr>
+      <p:sp>
+        <p:nvSpPr>
+          <p:cNvPr id="4" name="Rectangle 3">
+            <a:extLst>
+              <a:ext uri="{FF2B5EF4-FFF2-40B4-BE49-F238E27FC236}">
+                <a16:creationId xmlns:a16="http://schemas.microsoft.com/office/drawing/2014/main" id="{CE08B7F2-0052-098C-69C4-B4A71CE10609}"/>
+              </a:ext>
+            </a:extLst>
+          </p:cNvPr>
+          <p:cNvSpPr/>
+          <p:nvPr/>
+        </p:nvSpPr>
+        <p:spPr>
+          <a:xfrm>
+            <a:off x="1227668" y="5367866"/>
+            <a:ext cx="1761066" cy="812800"/>
+          </a:xfrm>
+          <a:prstGeom prst="rect">
+            <a:avLst/>
+          </a:prstGeom>
+        </p:spPr>
+        <p:style>
+          <a:lnRef idx="2">
+            <a:schemeClr val="dk1"/>
+          </a:lnRef>
+          <a:fillRef idx="1">
+            <a:schemeClr val="lt1"/>
+          </a:fillRef>
+          <a:effectRef idx="0">
+            <a:schemeClr val="dk1"/>
+          </a:effectRef>
+          <a:fontRef idx="minor">
+            <a:schemeClr val="dk1"/>
+          </a:fontRef>
+        </p:style>
+        <p:txBody>
+          <a:bodyPr rtlCol="0" anchor="ctr"/>
+          <a:lstStyle/>
+          <a:p>
+            <a:pPr algn="ctr"/>
+            <a:r>
+              <a:rPr lang="en-US" dirty="0"/>
+              <a:t>Node.js Server</a:t>
+            </a:r>
+          </a:p>
+        </p:txBody>
+      </p:sp>
+      <p:sp>
+        <p:nvSpPr>
+          <p:cNvPr id="5" name="Oval 4">
+            <a:extLst>
+              <a:ext uri="{FF2B5EF4-FFF2-40B4-BE49-F238E27FC236}">
+                <a16:creationId xmlns:a16="http://schemas.microsoft.com/office/drawing/2014/main" id="{000D2712-75D5-62D6-99A8-98E0DA72AB16}"/>
+              </a:ext>
+            </a:extLst>
+          </p:cNvPr>
+          <p:cNvSpPr/>
+          <p:nvPr/>
+        </p:nvSpPr>
+        <p:spPr>
+          <a:xfrm>
+            <a:off x="1354667" y="457200"/>
+            <a:ext cx="1507066" cy="795867"/>
+          </a:xfrm>
+          <a:prstGeom prst="ellipse">
+            <a:avLst/>
+          </a:prstGeom>
+        </p:spPr>
+        <p:style>
+          <a:lnRef idx="2">
+            <a:schemeClr val="dk1"/>
+          </a:lnRef>
+          <a:fillRef idx="1">
+            <a:schemeClr val="lt1"/>
+          </a:fillRef>
+          <a:effectRef idx="0">
+            <a:schemeClr val="dk1"/>
+          </a:effectRef>
+          <a:fontRef idx="minor">
+            <a:schemeClr val="dk1"/>
+          </a:fontRef>
+        </p:style>
+        <p:txBody>
+          <a:bodyPr rtlCol="0" anchor="ctr"/>
+          <a:lstStyle/>
+          <a:p>
+            <a:pPr algn="ctr"/>
+            <a:r>
+              <a:rPr lang="en-US" dirty="0"/>
+              <a:t>Web User</a:t>
+            </a:r>
+          </a:p>
+        </p:txBody>
+      </p:sp>
+      <p:sp>
+        <p:nvSpPr>
+          <p:cNvPr id="6" name="Rectangle 5">
+            <a:extLst>
+              <a:ext uri="{FF2B5EF4-FFF2-40B4-BE49-F238E27FC236}">
+                <a16:creationId xmlns:a16="http://schemas.microsoft.com/office/drawing/2014/main" id="{08FFD642-AD8E-9539-C917-143E084430FC}"/>
+              </a:ext>
+            </a:extLst>
+          </p:cNvPr>
+          <p:cNvSpPr/>
+          <p:nvPr/>
+        </p:nvSpPr>
+        <p:spPr>
+          <a:xfrm>
+            <a:off x="1092200" y="3073399"/>
+            <a:ext cx="2032000" cy="626533"/>
+          </a:xfrm>
+          <a:prstGeom prst="rect">
+            <a:avLst/>
+          </a:prstGeom>
+        </p:spPr>
+        <p:style>
+          <a:lnRef idx="2">
+            <a:schemeClr val="dk1"/>
+          </a:lnRef>
+          <a:fillRef idx="1">
+            <a:schemeClr val="lt1"/>
+          </a:fillRef>
+          <a:effectRef idx="0">
+            <a:schemeClr val="dk1"/>
+          </a:effectRef>
+          <a:fontRef idx="minor">
+            <a:schemeClr val="dk1"/>
+          </a:fontRef>
+        </p:style>
+        <p:txBody>
+          <a:bodyPr rtlCol="0" anchor="ctr"/>
+          <a:lstStyle/>
+          <a:p>
+            <a:pPr algn="ctr"/>
+            <a:r>
+              <a:rPr lang="en-US" dirty="0"/>
+              <a:t>To-Do list Website</a:t>
+            </a:r>
+          </a:p>
+        </p:txBody>
+      </p:sp>
+      <p:sp>
+        <p:nvSpPr>
+          <p:cNvPr id="7" name="Rectangle 6">
+            <a:extLst>
+              <a:ext uri="{FF2B5EF4-FFF2-40B4-BE49-F238E27FC236}">
+                <a16:creationId xmlns:a16="http://schemas.microsoft.com/office/drawing/2014/main" id="{43E91158-299E-6AAB-7EFD-7C51026C43B0}"/>
+              </a:ext>
+            </a:extLst>
+          </p:cNvPr>
+          <p:cNvSpPr/>
+          <p:nvPr/>
+        </p:nvSpPr>
+        <p:spPr>
+          <a:xfrm>
+            <a:off x="1100668" y="9533468"/>
+            <a:ext cx="2031999" cy="812800"/>
+          </a:xfrm>
+          <a:prstGeom prst="rect">
+            <a:avLst/>
+          </a:prstGeom>
+        </p:spPr>
+        <p:style>
+          <a:lnRef idx="2">
+            <a:schemeClr val="dk1"/>
+          </a:lnRef>
+          <a:fillRef idx="1">
+            <a:schemeClr val="lt1"/>
+          </a:fillRef>
+          <a:effectRef idx="0">
+            <a:schemeClr val="dk1"/>
+          </a:effectRef>
+          <a:fontRef idx="minor">
+            <a:schemeClr val="dk1"/>
+          </a:fontRef>
+        </p:style>
+        <p:txBody>
+          <a:bodyPr rtlCol="0" anchor="ctr"/>
+          <a:lstStyle/>
+          <a:p>
+            <a:pPr algn="ctr"/>
+            <a:r>
+              <a:rPr lang="en-US" dirty="0" err="1"/>
+              <a:t>Sql</a:t>
+            </a:r>
+            <a:r>
+              <a:rPr lang="en-US" dirty="0"/>
+              <a:t> Database</a:t>
+            </a:r>
+          </a:p>
+        </p:txBody>
+      </p:sp>
+      <p:cxnSp>
+        <p:nvCxnSpPr>
+          <p:cNvPr id="9" name="Straight Arrow Connector 8">
+            <a:extLst>
+              <a:ext uri="{FF2B5EF4-FFF2-40B4-BE49-F238E27FC236}">
+                <a16:creationId xmlns:a16="http://schemas.microsoft.com/office/drawing/2014/main" id="{24864908-1B40-71FA-2B6D-5AD0D1D9A19A}"/>
+              </a:ext>
+            </a:extLst>
+          </p:cNvPr>
+          <p:cNvCxnSpPr>
+            <a:stCxn id="5" idx="4"/>
+            <a:endCxn id="6" idx="0"/>
+          </p:cNvCxnSpPr>
+          <p:nvPr/>
+        </p:nvCxnSpPr>
+        <p:spPr>
+          <a:xfrm>
+            <a:off x="2108200" y="1253067"/>
+            <a:ext cx="0" cy="1820332"/>
+          </a:xfrm>
+          <a:prstGeom prst="straightConnector1">
+            <a:avLst/>
+          </a:prstGeom>
+          <a:ln>
+            <a:headEnd type="triangle"/>
+            <a:tailEnd type="triangle"/>
+          </a:ln>
+        </p:spPr>
+        <p:style>
+          <a:lnRef idx="2">
+            <a:schemeClr val="accent1"/>
+          </a:lnRef>
+          <a:fillRef idx="0">
+            <a:schemeClr val="accent1"/>
+          </a:fillRef>
+          <a:effectRef idx="1">
+            <a:schemeClr val="accent1"/>
+          </a:effectRef>
+          <a:fontRef idx="minor">
+            <a:schemeClr val="tx1"/>
+          </a:fontRef>
+        </p:style>
+      </p:cxnSp>
+      <p:cxnSp>
+        <p:nvCxnSpPr>
+          <p:cNvPr id="11" name="Straight Arrow Connector 10">
+            <a:extLst>
+              <a:ext uri="{FF2B5EF4-FFF2-40B4-BE49-F238E27FC236}">
+                <a16:creationId xmlns:a16="http://schemas.microsoft.com/office/drawing/2014/main" id="{6D5B87F2-49E3-600E-3268-CA7B9EDBB3B7}"/>
+              </a:ext>
+            </a:extLst>
+          </p:cNvPr>
+          <p:cNvCxnSpPr>
+            <a:stCxn id="6" idx="2"/>
+            <a:endCxn id="4" idx="0"/>
+          </p:cNvCxnSpPr>
+          <p:nvPr/>
+        </p:nvCxnSpPr>
+        <p:spPr>
+          <a:xfrm>
+            <a:off x="2108200" y="3699932"/>
+            <a:ext cx="1" cy="1667934"/>
+          </a:xfrm>
+          <a:prstGeom prst="straightConnector1">
+            <a:avLst/>
+          </a:prstGeom>
+          <a:ln>
+            <a:headEnd type="triangle"/>
+            <a:tailEnd type="triangle"/>
+          </a:ln>
+        </p:spPr>
+        <p:style>
+          <a:lnRef idx="2">
+            <a:schemeClr val="accent1"/>
+          </a:lnRef>
+          <a:fillRef idx="0">
+            <a:schemeClr val="accent1"/>
+          </a:fillRef>
+          <a:effectRef idx="1">
+            <a:schemeClr val="accent1"/>
+          </a:effectRef>
+          <a:fontRef idx="minor">
+            <a:schemeClr val="tx1"/>
+          </a:fontRef>
+        </p:style>
+      </p:cxnSp>
+      <p:cxnSp>
+        <p:nvCxnSpPr>
+          <p:cNvPr id="13" name="Straight Arrow Connector 12">
+            <a:extLst>
+              <a:ext uri="{FF2B5EF4-FFF2-40B4-BE49-F238E27FC236}">
+                <a16:creationId xmlns:a16="http://schemas.microsoft.com/office/drawing/2014/main" id="{DF11FF52-137F-3651-CE40-4539AC4A527A}"/>
+              </a:ext>
+            </a:extLst>
+          </p:cNvPr>
+          <p:cNvCxnSpPr>
+            <a:cxnSpLocks/>
+            <a:endCxn id="2" idx="0"/>
+          </p:cNvCxnSpPr>
+          <p:nvPr/>
+        </p:nvCxnSpPr>
+        <p:spPr>
+          <a:xfrm>
+            <a:off x="2108200" y="6180666"/>
+            <a:ext cx="8468" cy="1270001"/>
+          </a:xfrm>
+          <a:prstGeom prst="straightConnector1">
+            <a:avLst/>
+          </a:prstGeom>
+          <a:ln>
+            <a:headEnd type="triangle"/>
+            <a:tailEnd type="triangle"/>
+          </a:ln>
+        </p:spPr>
+        <p:style>
+          <a:lnRef idx="2">
+            <a:schemeClr val="accent1"/>
+          </a:lnRef>
+          <a:fillRef idx="0">
+            <a:schemeClr val="accent1"/>
+          </a:fillRef>
+          <a:effectRef idx="1">
+            <a:schemeClr val="accent1"/>
+          </a:effectRef>
+          <a:fontRef idx="minor">
+            <a:schemeClr val="tx1"/>
+          </a:fontRef>
+        </p:style>
+      </p:cxnSp>
+      <p:sp>
+        <p:nvSpPr>
+          <p:cNvPr id="2" name="Rectangle 1">
+            <a:extLst>
+              <a:ext uri="{FF2B5EF4-FFF2-40B4-BE49-F238E27FC236}">
+                <a16:creationId xmlns:a16="http://schemas.microsoft.com/office/drawing/2014/main" id="{F7909B2B-4DCF-32B3-B3E5-38B89930146E}"/>
+              </a:ext>
+            </a:extLst>
+          </p:cNvPr>
+          <p:cNvSpPr/>
+          <p:nvPr/>
+        </p:nvSpPr>
+        <p:spPr>
+          <a:xfrm>
+            <a:off x="1100668" y="7450667"/>
+            <a:ext cx="2031999" cy="812800"/>
+          </a:xfrm>
+          <a:prstGeom prst="rect">
+            <a:avLst/>
+          </a:prstGeom>
+        </p:spPr>
+        <p:style>
+          <a:lnRef idx="2">
+            <a:schemeClr val="dk1"/>
+          </a:lnRef>
+          <a:fillRef idx="1">
+            <a:schemeClr val="lt1"/>
+          </a:fillRef>
+          <a:effectRef idx="0">
+            <a:schemeClr val="dk1"/>
+          </a:effectRef>
+          <a:fontRef idx="minor">
+            <a:schemeClr val="dk1"/>
+          </a:fontRef>
+        </p:style>
+        <p:txBody>
+          <a:bodyPr rtlCol="0" anchor="ctr"/>
+          <a:lstStyle/>
+          <a:p>
+            <a:pPr algn="ctr"/>
+            <a:r>
+              <a:rPr lang="en-US" dirty="0"/>
+              <a:t>Database Controller</a:t>
+            </a:r>
+          </a:p>
+        </p:txBody>
+      </p:sp>
+      <p:cxnSp>
+        <p:nvCxnSpPr>
+          <p:cNvPr id="10" name="Straight Arrow Connector 9">
+            <a:extLst>
+              <a:ext uri="{FF2B5EF4-FFF2-40B4-BE49-F238E27FC236}">
+                <a16:creationId xmlns:a16="http://schemas.microsoft.com/office/drawing/2014/main" id="{6DB1FDC8-9C26-AD4C-B08B-8606D3D3DD0F}"/>
+              </a:ext>
+            </a:extLst>
+          </p:cNvPr>
+          <p:cNvCxnSpPr>
+            <a:cxnSpLocks/>
+            <a:stCxn id="2" idx="2"/>
+            <a:endCxn id="7" idx="0"/>
+          </p:cNvCxnSpPr>
+          <p:nvPr/>
+        </p:nvCxnSpPr>
+        <p:spPr>
+          <a:xfrm>
+            <a:off x="2116668" y="8263467"/>
+            <a:ext cx="0" cy="1270001"/>
+          </a:xfrm>
+          <a:prstGeom prst="straightConnector1">
+            <a:avLst/>
+          </a:prstGeom>
+          <a:ln>
+            <a:headEnd type="triangle"/>
+            <a:tailEnd type="triangle"/>
+          </a:ln>
+        </p:spPr>
+        <p:style>
+          <a:lnRef idx="2">
+            <a:schemeClr val="accent1"/>
+          </a:lnRef>
+          <a:fillRef idx="0">
+            <a:schemeClr val="accent1"/>
+          </a:fillRef>
+          <a:effectRef idx="1">
+            <a:schemeClr val="accent1"/>
+          </a:effectRef>
+          <a:fontRef idx="minor">
+            <a:schemeClr val="tx1"/>
+          </a:fontRef>
+        </p:style>
+      </p:cxnSp>
+      <p:sp>
+        <p:nvSpPr>
+          <p:cNvPr id="15" name="Oval 14">
+            <a:extLst>
+              <a:ext uri="{FF2B5EF4-FFF2-40B4-BE49-F238E27FC236}">
+                <a16:creationId xmlns:a16="http://schemas.microsoft.com/office/drawing/2014/main" id="{FB6D6608-1B4F-7F01-4196-CDD263D9F8BA}"/>
+              </a:ext>
+            </a:extLst>
+          </p:cNvPr>
+          <p:cNvSpPr/>
+          <p:nvPr/>
+        </p:nvSpPr>
+        <p:spPr>
+          <a:xfrm>
+            <a:off x="4741334" y="7467600"/>
+            <a:ext cx="1507066" cy="795867"/>
+          </a:xfrm>
+          <a:prstGeom prst="ellipse">
+            <a:avLst/>
+          </a:prstGeom>
+        </p:spPr>
+        <p:style>
+          <a:lnRef idx="2">
+            <a:schemeClr val="dk1"/>
+          </a:lnRef>
+          <a:fillRef idx="1">
+            <a:schemeClr val="lt1"/>
+          </a:fillRef>
+          <a:effectRef idx="0">
+            <a:schemeClr val="dk1"/>
+          </a:effectRef>
+          <a:fontRef idx="minor">
+            <a:schemeClr val="dk1"/>
+          </a:fontRef>
+        </p:style>
+        <p:txBody>
+          <a:bodyPr rtlCol="0" anchor="ctr"/>
+          <a:lstStyle/>
+          <a:p>
+            <a:pPr algn="ctr"/>
+            <a:r>
+              <a:rPr lang="en-US" dirty="0"/>
+              <a:t>Web User</a:t>
+            </a:r>
+          </a:p>
+        </p:txBody>
+      </p:sp>
+      <p:cxnSp>
+        <p:nvCxnSpPr>
+          <p:cNvPr id="17" name="Straight Arrow Connector 16">
+            <a:extLst>
+              <a:ext uri="{FF2B5EF4-FFF2-40B4-BE49-F238E27FC236}">
+                <a16:creationId xmlns:a16="http://schemas.microsoft.com/office/drawing/2014/main" id="{80BC38C3-39D6-66D2-F3B1-AA5AE7F86F20}"/>
+              </a:ext>
+            </a:extLst>
+          </p:cNvPr>
+          <p:cNvCxnSpPr>
+            <a:stCxn id="2" idx="3"/>
+            <a:endCxn id="15" idx="2"/>
+          </p:cNvCxnSpPr>
+          <p:nvPr/>
+        </p:nvCxnSpPr>
+        <p:spPr>
+          <a:xfrm>
+            <a:off x="3132667" y="7857067"/>
+            <a:ext cx="1608667" cy="8467"/>
+          </a:xfrm>
+          <a:prstGeom prst="straightConnector1">
+            <a:avLst/>
+          </a:prstGeom>
+          <a:ln>
+            <a:headEnd type="triangle"/>
+            <a:tailEnd type="triangle"/>
+          </a:ln>
+        </p:spPr>
+        <p:style>
+          <a:lnRef idx="2">
+            <a:schemeClr val="accent1"/>
+          </a:lnRef>
+          <a:fillRef idx="0">
+            <a:schemeClr val="accent1"/>
+          </a:fillRef>
+          <a:effectRef idx="1">
+            <a:schemeClr val="accent1"/>
+          </a:effectRef>
+          <a:fontRef idx="minor">
+            <a:schemeClr val="tx1"/>
+          </a:fontRef>
+        </p:style>
+      </p:cxnSp>
+    </p:spTree>
+    <p:extLst>
+      <p:ext uri="{BB962C8B-B14F-4D97-AF65-F5344CB8AC3E}">
+        <p14:creationId xmlns:p14="http://schemas.microsoft.com/office/powerpoint/2010/main" val="1281802143"/>
+      </p:ext>
+    </p:extLst>
+  </p:cSld>
+  <p:clrMapOvr>
+    <a:masterClrMapping/>
+  </p:clrMapOvr>
+</p:sld>
+</file>
+
 <file path=ppt/theme/theme1.xml><?xml version="1.0" encoding="utf-8"?>
 <a:theme xmlns:a="http://schemas.openxmlformats.org/drawingml/2006/main" name="Office Theme">
   <a:themeElements>

</xml_diff>